<commit_message>
docs: correct test counts and coverage to the verified figures
The documentation cited 255 tests at 92.55%, which was accurate before the
ProxyFix regression tests were added. The verified figures are 264 tests
(177 unit, 87 integration) at 92.69% coverage.

The '255 tests' references in the HSTS defect narrative are left as they are:
they correctly describe the suite size at the moment that defect slipped
through, which is the point being made.

Co-Authored-By: Claude Opus 5 <noreply@anthropic.com>
</commit_message>
<xml_diff>
--- a/reports/submission/presentation.pptx
+++ b/reports/submission/presentation.pptx
@@ -4592,14 +4592,14 @@
             <a:pPr lvl="1"/>
             <a:r>
               <a:rPr sz="1700"/>
-              <a:t>unit-tests · 159 tests</a:t>
+              <a:t>unit-tests · 177 tests</a:t>
             </a:r>
           </a:p>
           <a:p>
             <a:pPr lvl="1"/>
             <a:r>
               <a:rPr sz="1700"/>
-              <a:t>integration-tests · 105 tests, on PostgreSQL 16</a:t>
+              <a:t>integration-tests · 87 tests, on PostgreSQL 16</a:t>
             </a:r>
           </a:p>
           <a:p>
@@ -4704,7 +4704,7 @@
             <a:pPr/>
             <a:r>
               <a:rPr sz="2000"/>
-              <a:t>Unit (159) — validation, the decision table, business rules, audit</a:t>
+              <a:t>Unit (177) — validation, the decision table, business rules, audit</a:t>
             </a:r>
           </a:p>
           <a:p>
@@ -4718,7 +4718,7 @@
             <a:pPr/>
             <a:r>
               <a:rPr sz="2000"/>
-              <a:t>Integration (105) — full workflows, access control, security properties</a:t>
+              <a:t>Integration (87) — full workflows, access control, security properties</a:t>
             </a:r>
           </a:p>
           <a:p>

</xml_diff>